<commit_message>
Lezione 5: login con passkey o account personale, nessun IdP aziendale richiesto
</commit_message>
<xml_diff>
--- a/slide/slide-5-tailscale.pptx
+++ b/slide/slide-5-tailscale.pptx
@@ -522,7 +522,7 @@
           <a:p>
             <a:r>
               <a:rPr lang="en-US" dirty="0"/>
-              <a:t>La nostra rete è privata: il server della lezione 4 e il database della lezione 6 non si raggiungono da internet. Ma amministratori e sviluppatori, da casa, devono poterci lavorare. Oggi costruiamo un accesso sicuro con Tailscale: un piccolo router dentro la rete, il login di Google, Microsoft o GitHub con la sua MFA, e permessi diversi per gruppo. Alla fine aprirete dal vostro computer la pagina del server della lezione 4.</a:t>
+              <a:t>La nostra rete è privata: il server della lezione 4 e il database della lezione 6 non si raggiungono da internet. Ma amministratori e sviluppatori, da casa, devono poterci lavorare. Oggi costruiamo un accesso sicuro con Tailscale: un piccolo router dentro la rete, il login con una passkey o un account personale con MFA, senza nessun sistema aziendale, e permessi diversi per gruppo. Alla fine aprirete dal vostro computer la pagina del server della lezione 4.</a:t>
             </a:r>
             <a:endParaRPr lang="en-US" dirty="0"/>
           </a:p>
@@ -874,7 +874,7 @@
           <a:p>
             <a:r>
               <a:rPr lang="en-US" dirty="0"/>
-              <a:t>Il codice. In providers.tf aggiungiamo il provider di Tailscale, che gestisce il tailnet dal codice; ha bisogno di una chiave API, che come le credenziali AWS non va mai nel codice: la legge dalla variabile d'ambiente TAILSCALE_API_KEY. Dopo va rilanciato terraform init. In variables.tf due liste di email: gli amministratori e gli sviluppatori. E il file nuovo tailscale.tf, in quattro parti: la policy, la chiave d'ingresso, le uscite del SG vpn, il router.</a:t>
+              <a:t>Il codice. In providers.tf aggiungiamo il provider di Tailscale, che gestisce il tailnet dal codice; ha bisogno di una chiave API, che come le credenziali AWS non va mai nel codice: la legge dalla variabile d'ambiente TAILSCALE_API_KEY. Dopo va rilanciato terraform init. In variables.tf due liste di nomi di login Tailscale: gli amministratori e gli sviluppatori. E il file nuovo tailscale.tf, in quattro parti: la policy, la chiave d'ingresso, le uscite del SG vpn, il router.</a:t>
             </a:r>
             <a:endParaRPr lang="en-US" dirty="0"/>
           </a:p>
@@ -1314,7 +1314,7 @@
           <a:p>
             <a:r>
               <a:rPr lang="en-US" dirty="0"/>
-              <a:t>L'esercizio. Uno: verificate che l'account con cui entrate in Tailscale abbia la verifica in due passaggi; installate Tailscale sul vostro computer e fate il login. Due: create una chiave API nella console di Tailscale e mettetela nel terminale con export, mai nei file. Tre: scrivete la vostra email in tailscale_admins nel tfvars. Quattro: init, perché c'è un provider nuovo, poi plan e apply; il router impiega un paio di minuti. Cinque: nella console di Tailscale, Machines, compare il router con l'etichetta e le subnet già approvate.</a:t>
+              <a:t>L'esercizio. Uno: create l'account Tailscale con una passkey, oppure con un account personale che abbia la verifica in due passaggi; installate Tailscale sul vostro computer e fate il login. Due: create una chiave API nella console di Tailscale e mettetela nel terminale con export, mai nei file. Tre: scrivete il vostro nome di login, che trovate alla voce Users, in tailscale_admins nel tfvars. Quattro: init, perché c'è un provider nuovo, poi plan e apply; il router impiega un paio di minuti. Cinque: nella console di Tailscale, Machines, compare il router con l'etichetta e le subnet già approvate.</a:t>
             </a:r>
             <a:endParaRPr lang="en-US" dirty="0"/>
           </a:p>
@@ -2106,7 +2106,7 @@
           <a:p>
             <a:r>
               <a:rPr lang="en-US" dirty="0"/>
-              <a:t>Tailscale non ha password sue: per entrare nel tailnet si fa il login con un account esistente, per esempio Google, Microsoft o GitHub. È quel servizio a verificare chi siete. Da qui la regola più importante: l'MFA la fa il servizio di login. Se l'account Google ha la verifica in due passaggi, per entrare servono password e codice dal telefono; se non ce l'ha, la VPN è protetta da una sola password. Per tutti, la verifica in due passaggi è obbligatoria. In più Tailscale fa scadere periodicamente il login dei dispositivi, e può chiedere l'approvazione di ogni nuovo dispositivo. Quando qualcuno lascia l'azienda, si disattiva il suo account e perde subito l'accesso.</a:t>
+              <a:t>Tailscale non ha password sue, e non serve nessun sistema di login aziendale. Ci si identifica in due modi semplici. Con una passkey: ci si registra su Tailscale con l'impronta, il viso o il PIN del computer o del telefono, senza nessun account esterno. Il secondo fattore c'è già, perché servono il dispositivo e l'impronta, ed è il modo più resistente al phishing: è quello consigliato. Oppure con un account personale Google, Microsoft o GitHub, che deve avere la verifica in due passaggi attiva. La regola: nessuno entra nel tailnet con una password sola. Nei gruppi della policy ogni persona si indica con il suo nome di login, che si legge nella console di Tailscale alla voce Users. Quando qualcuno lascia il gruppo, lo si rimuove da Tailscale e perde subito l'accesso.</a:t>
             </a:r>
             <a:endParaRPr lang="en-US" dirty="0"/>
           </a:p>
@@ -2901,7 +2901,7 @@
                 <a:ea typeface="Calibri" pitchFamily="34" charset="-122"/>
                 <a:cs typeface="Calibri" pitchFamily="34" charset="-120"/>
               </a:rPr>
-              <a:t>Raggiungere la rete privata da casa, con il login che usi già e la sua MFA</a:t>
+              <a:t>Raggiungere la rete privata da casa, con una passkey o un account personale: niente login aziendale</a:t>
             </a:r>
             <a:endParaRPr lang="en-US" sz="2000" dirty="0"/>
           </a:p>
@@ -6836,7 +6836,7 @@
                 <a:ea typeface="Courier New" pitchFamily="34" charset="-122"/>
                 <a:cs typeface="Courier New" pitchFamily="34" charset="-120"/>
               </a:rPr>
-              <a:t># email</a:t>
+              <a:t># nomi di login</a:t>
             </a:r>
             <a:endParaRPr lang="en-US" sz="1500" dirty="0"/>
           </a:p>
@@ -6901,7 +6901,7 @@
                 <a:ea typeface="Courier New" pitchFamily="34" charset="-122"/>
                 <a:cs typeface="Courier New" pitchFamily="34" charset="-120"/>
               </a:rPr>
-              <a:t># email</a:t>
+              <a:t># nomi di login</a:t>
             </a:r>
             <a:endParaRPr lang="en-US" sz="1500" dirty="0"/>
           </a:p>
@@ -10626,7 +10626,7 @@
                 <a:ea typeface="Calibri" pitchFamily="34" charset="-122"/>
                 <a:cs typeface="Calibri" pitchFamily="34" charset="-120"/>
               </a:rPr>
-              <a:t>Account con MFA + Tailscale sul tuo computer</a:t>
+              <a:t>Account Tailscale con passkey (o account personale con MFA)</a:t>
             </a:r>
             <a:endParaRPr lang="en-US" sz="1800" dirty="0"/>
           </a:p>
@@ -10643,7 +10643,7 @@
                 <a:ea typeface="Calibri" pitchFamily="34" charset="-122"/>
                 <a:cs typeface="Calibri" pitchFamily="34" charset="-120"/>
               </a:rPr>
-              <a:t>La verifica in due passaggi deve essere attiva · login · il tuo PC compare con un indirizzo 100.x.y.z</a:t>
+              <a:t>Installa Tailscale e fai il login · il tuo PC compare con un indirizzo 100.x.y.z · in Users: il tuo nome di login</a:t>
             </a:r>
             <a:endParaRPr lang="en-US" sz="1800" dirty="0"/>
           </a:p>
@@ -10866,7 +10866,7 @@
                 <a:ea typeface="Calibri" pitchFamily="34" charset="-122"/>
                 <a:cs typeface="Calibri" pitchFamily="34" charset="-120"/>
               </a:rPr>
-              <a:t>terraform.tfvars: tailscale_admins = ["tu@example.com"]</a:t>
+              <a:t>terraform.tfvars: tailscale_admins = ["il-tuo-nome-di-login"]</a:t>
             </a:r>
             <a:endParaRPr lang="en-US" sz="1800" dirty="0"/>
           </a:p>
@@ -10883,7 +10883,7 @@
                 <a:ea typeface="Calibri" pitchFamily="34" charset="-122"/>
                 <a:cs typeface="Calibri" pitchFamily="34" charset="-120"/>
               </a:rPr>
-              <a:t>l'email con cui hai fatto il login in Tailscale</a:t>
+              <a:t>il nome che trovi nella console di Tailscale, alla voce Users</a:t>
             </a:r>
             <a:endParaRPr lang="en-US" sz="1800" dirty="0"/>
           </a:p>
@@ -15020,7 +15020,7 @@
                           <a:ea typeface="Calibri" pitchFamily="34" charset="-122"/>
                           <a:cs typeface="Calibri" pitchFamily="34" charset="-120"/>
                         </a:rPr>
-                        <a:t>MFA</a:t>
+                        <a:t>passkey</a:t>
                       </a:r>
                       <a:endParaRPr lang="en-US" sz="1500" dirty="0">
                         <a:latin typeface="Calibri" charset="0"/>
@@ -15088,7 +15088,7 @@
                           <a:ea typeface="Calibri" pitchFamily="34" charset="-122"/>
                           <a:cs typeface="Calibri" pitchFamily="34" charset="-120"/>
                         </a:rPr>
-                        <a:t>il codice dal telefono, del login</a:t>
+                        <a:t>login con impronta o PIN: MFA inclusa</a:t>
                       </a:r>
                       <a:endParaRPr lang="en-US" sz="1500" dirty="0">
                         <a:latin typeface="Calibri" charset="0"/>
@@ -15478,7 +15478,7 @@
                 <a:ea typeface="Calibri" pitchFamily="34" charset="-122"/>
                 <a:cs typeface="Calibri" pitchFamily="34" charset="-120"/>
               </a:rPr>
-              <a:t>Login di Google/Microsoft/GitHub: l'MFA la fa lui, obbligatoria</a:t>
+              <a:t>Passkey o account personale con MFA: nessun login aziendale</a:t>
             </a:r>
             <a:endParaRPr lang="en-US" sz="1800" dirty="0"/>
           </a:p>
@@ -16197,7 +16197,7 @@
                 <a:ea typeface="Calibri" pitchFamily="34" charset="-122"/>
                 <a:cs typeface="Calibri" pitchFamily="34" charset="-120"/>
               </a:rPr>
-              <a:t>AWS Client VPN si paga a ore per ogni subnet collegata, anche se nessuno la usa, e il login con MFA è lungo da configurare. Tailscale: piano gratuito per piccoli gruppi, un server piccolissimo su AWS, e l'MFA del login che usi già.</a:t>
+              <a:t>AWS Client VPN si paga a ore per ogni subnet collegata, anche se nessuno la usa, e il login con MFA è lungo da configurare. Tailscale: piano gratuito per piccoli gruppi, un server piccolissimo su AWS, e l'MFA arriva da una passkey o dal tuo account personale: nessun login aziendale.</a:t>
             </a:r>
             <a:endParaRPr lang="en-US" sz="1600" dirty="0"/>
           </a:p>
@@ -18601,7 +18601,7 @@
                 <a:ea typeface="Calibri" pitchFamily="34" charset="-122"/>
                 <a:cs typeface="Calibri" pitchFamily="34" charset="-120"/>
               </a:rPr>
-              <a:t>Chi si collega: il login che usi già, e la sua MFA</a:t>
+              <a:t>Chi si collega: passkey o account personale, sempre con MFA</a:t>
             </a:r>
             <a:endParaRPr lang="en-US" sz="3200" dirty="0"/>
           </a:p>
@@ -18655,11 +18655,11 @@
         <p:spPr>
           <a:xfrm>
             <a:off x="548640" y="1280160"/>
-            <a:ext cx="11094415" cy="914400"/>
+            <a:ext cx="11094415" cy="777240"/>
           </a:xfrm>
           <a:prstGeom prst="roundRect">
             <a:avLst>
-              <a:gd name="adj" fmla="val 10000"/>
+              <a:gd name="adj" fmla="val 11765"/>
             </a:avLst>
           </a:prstGeom>
           <a:solidFill>
@@ -18682,7 +18682,7 @@
         <p:spPr>
           <a:xfrm>
             <a:off x="822960" y="1280160"/>
-            <a:ext cx="10545775" cy="914400"/>
+            <a:ext cx="10545775" cy="777240"/>
           </a:xfrm>
           <a:prstGeom prst="rect">
             <a:avLst/>
@@ -18706,7 +18706,7 @@
                 <a:ea typeface="Calibri" pitchFamily="34" charset="-122"/>
                 <a:cs typeface="Calibri" pitchFamily="34" charset="-120"/>
               </a:rPr>
-              <a:t>L'MFA la fa il servizio di login (Google, Microsoft, GitHub): per tutti la verifica in due passaggi è OBBLIGATORIA.</a:t>
+              <a:t>Nessun login aziendale necessario. Regola: nessuno entra nel tailnet con una password sola.</a:t>
             </a:r>
             <a:endParaRPr lang="en-US" sz="1900" dirty="0"/>
           </a:p>
@@ -18720,12 +18720,412 @@
         </p:nvSpPr>
         <p:spPr>
           <a:xfrm>
-            <a:off x="548640" y="2423160"/>
-            <a:ext cx="5440680" cy="1645920"/>
+            <a:off x="548640" y="2286000"/>
+            <a:ext cx="5440680" cy="2377440"/>
           </a:xfrm>
           <a:prstGeom prst="roundRect">
             <a:avLst>
-              <a:gd name="adj" fmla="val 6667"/>
+              <a:gd name="adj" fmla="val 4615"/>
+            </a:avLst>
+          </a:prstGeom>
+          <a:solidFill>
+            <a:srgbClr val="E5F4EC"/>
+          </a:solidFill>
+          <a:ln w="12700">
+            <a:solidFill>
+              <a:srgbClr val="E5F4EC"/>
+            </a:solidFill>
+            <a:prstDash val="solid"/>
+          </a:ln>
+        </p:spPr>
+      </p:sp>
+      <p:sp>
+        <p:nvSpPr>
+          <p:cNvPr id="8" name="Shape 5"/>
+          <p:cNvSpPr/>
+          <p:nvPr/>
+        </p:nvSpPr>
+        <p:spPr>
+          <a:xfrm>
+            <a:off x="777240" y="2514600"/>
+            <a:ext cx="548640" cy="548640"/>
+          </a:xfrm>
+          <a:prstGeom prst="ellipse">
+            <a:avLst/>
+          </a:prstGeom>
+          <a:solidFill>
+            <a:srgbClr val="2E9E6B"/>
+          </a:solidFill>
+          <a:ln w="12700">
+            <a:solidFill>
+              <a:srgbClr val="2E9E6B"/>
+            </a:solidFill>
+            <a:prstDash val="solid"/>
+          </a:ln>
+        </p:spPr>
+      </p:sp>
+      <p:pic>
+        <p:nvPicPr>
+          <p:cNvPr id="9" name="Image 0" descr="preencoded.png">    </p:cNvPr>
+          <p:cNvPicPr>
+            <a:picLocks noChangeAspect="1"/>
+          </p:cNvPicPr>
+          <p:nvPr/>
+        </p:nvPicPr>
+        <p:blipFill>
+          <a:blip r:embed="rId1"/>
+          <a:stretch>
+            <a:fillRect/>
+          </a:stretch>
+        </p:blipFill>
+        <p:spPr>
+          <a:xfrm>
+            <a:off x="914400" y="2651760"/>
+            <a:ext cx="274320" cy="274320"/>
+          </a:xfrm>
+          <a:prstGeom prst="rect">
+            <a:avLst/>
+          </a:prstGeom>
+        </p:spPr>
+      </p:pic>
+      <p:sp>
+        <p:nvSpPr>
+          <p:cNvPr id="10" name="Text 6"/>
+          <p:cNvSpPr txBox="1"/>
+          <p:nvPr/>
+        </p:nvSpPr>
+        <p:spPr>
+          <a:xfrm>
+            <a:off x="1508760" y="2514600"/>
+            <a:ext cx="4251960" cy="548640"/>
+          </a:xfrm>
+          <a:prstGeom prst="rect">
+            <a:avLst/>
+          </a:prstGeom>
+          <a:noFill/>
+          <a:ln/>
+        </p:spPr>
+        <p:txBody>
+          <a:bodyPr wrap="square" lIns="0" tIns="0" rIns="0" bIns="0" rtlCol="0" anchor="ctr"/>
+          <a:lstStyle/>
+          <a:p>
+            <a:pPr indent="0" marL="0">
+              <a:buNone/>
+            </a:pPr>
+            <a:r>
+              <a:rPr lang="en-US" sz="1800" b="1" dirty="0">
+                <a:solidFill>
+                  <a:srgbClr val="22253A"/>
+                </a:solidFill>
+                <a:latin typeface="Calibri" pitchFamily="34" charset="0"/>
+                <a:ea typeface="Calibri" pitchFamily="34" charset="-122"/>
+                <a:cs typeface="Calibri" pitchFamily="34" charset="-120"/>
+              </a:rPr>
+              <a:t>Passkey (consigliata)</a:t>
+            </a:r>
+            <a:endParaRPr lang="en-US" sz="1800" dirty="0"/>
+          </a:p>
+        </p:txBody>
+      </p:sp>
+      <p:sp>
+        <p:nvSpPr>
+          <p:cNvPr id="11" name="Text 7"/>
+          <p:cNvSpPr txBox="1"/>
+          <p:nvPr/>
+        </p:nvSpPr>
+        <p:spPr>
+          <a:xfrm>
+            <a:off x="777240" y="3200400"/>
+            <a:ext cx="4983480" cy="1280160"/>
+          </a:xfrm>
+          <a:prstGeom prst="rect">
+            <a:avLst/>
+          </a:prstGeom>
+          <a:noFill/>
+          <a:ln/>
+        </p:spPr>
+        <p:txBody>
+          <a:bodyPr wrap="square" lIns="0" tIns="0" rIns="0" bIns="0" rtlCol="0" anchor="t"/>
+          <a:lstStyle/>
+          <a:p>
+            <a:pPr marL="342900" indent="-342900">
+              <a:spcAft>
+                <a:spcPts val="600"/>
+              </a:spcAft>
+              <a:buSzPct val="100000"/>
+              <a:buChar char="•"/>
+            </a:pPr>
+            <a:r>
+              <a:rPr lang="en-US" sz="1600" dirty="0">
+                <a:solidFill>
+                  <a:srgbClr val="22253A"/>
+                </a:solidFill>
+                <a:latin typeface="Calibri" pitchFamily="34" charset="0"/>
+                <a:ea typeface="Calibri" pitchFamily="34" charset="-122"/>
+                <a:cs typeface="Calibri" pitchFamily="34" charset="-120"/>
+              </a:rPr>
+              <a:t>Impronta, viso o PIN del tuo computer o telefono</a:t>
+            </a:r>
+            <a:endParaRPr lang="en-US" sz="1600" dirty="0"/>
+          </a:p>
+          <a:p>
+            <a:pPr marL="342900" indent="-342900">
+              <a:spcAft>
+                <a:spcPts val="600"/>
+              </a:spcAft>
+              <a:buSzPct val="100000"/>
+              <a:buChar char="•"/>
+            </a:pPr>
+            <a:r>
+              <a:rPr lang="en-US" sz="1600" dirty="0">
+                <a:solidFill>
+                  <a:srgbClr val="22253A"/>
+                </a:solidFill>
+                <a:latin typeface="Calibri" pitchFamily="34" charset="0"/>
+                <a:ea typeface="Calibri" pitchFamily="34" charset="-122"/>
+                <a:cs typeface="Calibri" pitchFamily="34" charset="-120"/>
+              </a:rPr>
+              <a:t>Nessun account esterno</a:t>
+            </a:r>
+            <a:endParaRPr lang="en-US" sz="1600" dirty="0"/>
+          </a:p>
+          <a:p>
+            <a:pPr marL="342900" indent="-342900">
+              <a:spcAft>
+                <a:spcPts val="600"/>
+              </a:spcAft>
+              <a:buSzPct val="100000"/>
+              <a:buChar char="•"/>
+            </a:pPr>
+            <a:r>
+              <a:rPr lang="en-US" sz="1600" dirty="0">
+                <a:solidFill>
+                  <a:srgbClr val="22253A"/>
+                </a:solidFill>
+                <a:latin typeface="Calibri" pitchFamily="34" charset="0"/>
+                <a:ea typeface="Calibri" pitchFamily="34" charset="-122"/>
+                <a:cs typeface="Calibri" pitchFamily="34" charset="-120"/>
+              </a:rPr>
+              <a:t>MFA già inclusa: dispositivo + impronta/PIN</a:t>
+            </a:r>
+            <a:endParaRPr lang="en-US" sz="1600" dirty="0"/>
+          </a:p>
+        </p:txBody>
+      </p:sp>
+      <p:sp>
+        <p:nvSpPr>
+          <p:cNvPr id="12" name="Shape 8"/>
+          <p:cNvSpPr/>
+          <p:nvPr/>
+        </p:nvSpPr>
+        <p:spPr>
+          <a:xfrm>
+            <a:off x="6172200" y="2286000"/>
+            <a:ext cx="5468112" cy="2377440"/>
+          </a:xfrm>
+          <a:prstGeom prst="roundRect">
+            <a:avLst>
+              <a:gd name="adj" fmla="val 4615"/>
+            </a:avLst>
+          </a:prstGeom>
+          <a:solidFill>
+            <a:srgbClr val="FDF0E3"/>
+          </a:solidFill>
+          <a:ln w="12700">
+            <a:solidFill>
+              <a:srgbClr val="FDF0E3"/>
+            </a:solidFill>
+            <a:prstDash val="solid"/>
+          </a:ln>
+        </p:spPr>
+      </p:sp>
+      <p:sp>
+        <p:nvSpPr>
+          <p:cNvPr id="13" name="Shape 9"/>
+          <p:cNvSpPr/>
+          <p:nvPr/>
+        </p:nvSpPr>
+        <p:spPr>
+          <a:xfrm>
+            <a:off x="6400800" y="2514600"/>
+            <a:ext cx="548640" cy="548640"/>
+          </a:xfrm>
+          <a:prstGeom prst="ellipse">
+            <a:avLst/>
+          </a:prstGeom>
+          <a:solidFill>
+            <a:srgbClr val="F28C28"/>
+          </a:solidFill>
+          <a:ln w="12700">
+            <a:solidFill>
+              <a:srgbClr val="F28C28"/>
+            </a:solidFill>
+            <a:prstDash val="solid"/>
+          </a:ln>
+        </p:spPr>
+      </p:sp>
+      <p:pic>
+        <p:nvPicPr>
+          <p:cNvPr id="14" name="Image 1" descr="preencoded.png">    </p:cNvPr>
+          <p:cNvPicPr>
+            <a:picLocks noChangeAspect="1"/>
+          </p:cNvPicPr>
+          <p:nvPr/>
+        </p:nvPicPr>
+        <p:blipFill>
+          <a:blip r:embed="rId2"/>
+          <a:stretch>
+            <a:fillRect/>
+          </a:stretch>
+        </p:blipFill>
+        <p:spPr>
+          <a:xfrm>
+            <a:off x="6537960" y="2651760"/>
+            <a:ext cx="274320" cy="274320"/>
+          </a:xfrm>
+          <a:prstGeom prst="rect">
+            <a:avLst/>
+          </a:prstGeom>
+        </p:spPr>
+      </p:pic>
+      <p:sp>
+        <p:nvSpPr>
+          <p:cNvPr id="15" name="Text 10"/>
+          <p:cNvSpPr txBox="1"/>
+          <p:nvPr/>
+        </p:nvSpPr>
+        <p:spPr>
+          <a:xfrm>
+            <a:off x="7132320" y="2514600"/>
+            <a:ext cx="4279392" cy="548640"/>
+          </a:xfrm>
+          <a:prstGeom prst="rect">
+            <a:avLst/>
+          </a:prstGeom>
+          <a:noFill/>
+          <a:ln/>
+        </p:spPr>
+        <p:txBody>
+          <a:bodyPr wrap="square" lIns="0" tIns="0" rIns="0" bIns="0" rtlCol="0" anchor="ctr"/>
+          <a:lstStyle/>
+          <a:p>
+            <a:pPr indent="0" marL="0">
+              <a:buNone/>
+            </a:pPr>
+            <a:r>
+              <a:rPr lang="en-US" sz="1800" b="1" dirty="0">
+                <a:solidFill>
+                  <a:srgbClr val="22253A"/>
+                </a:solidFill>
+                <a:latin typeface="Calibri" pitchFamily="34" charset="0"/>
+                <a:ea typeface="Calibri" pitchFamily="34" charset="-122"/>
+                <a:cs typeface="Calibri" pitchFamily="34" charset="-120"/>
+              </a:rPr>
+              <a:t>Account personale</a:t>
+            </a:r>
+            <a:endParaRPr lang="en-US" sz="1800" dirty="0"/>
+          </a:p>
+        </p:txBody>
+      </p:sp>
+      <p:sp>
+        <p:nvSpPr>
+          <p:cNvPr id="16" name="Text 11"/>
+          <p:cNvSpPr txBox="1"/>
+          <p:nvPr/>
+        </p:nvSpPr>
+        <p:spPr>
+          <a:xfrm>
+            <a:off x="6400800" y="3200400"/>
+            <a:ext cx="5010912" cy="1280160"/>
+          </a:xfrm>
+          <a:prstGeom prst="rect">
+            <a:avLst/>
+          </a:prstGeom>
+          <a:noFill/>
+          <a:ln/>
+        </p:spPr>
+        <p:txBody>
+          <a:bodyPr wrap="square" lIns="0" tIns="0" rIns="0" bIns="0" rtlCol="0" anchor="t"/>
+          <a:lstStyle/>
+          <a:p>
+            <a:pPr marL="342900" indent="-342900">
+              <a:spcAft>
+                <a:spcPts val="600"/>
+              </a:spcAft>
+              <a:buSzPct val="100000"/>
+              <a:buChar char="•"/>
+            </a:pPr>
+            <a:r>
+              <a:rPr lang="en-US" sz="1600" dirty="0">
+                <a:solidFill>
+                  <a:srgbClr val="22253A"/>
+                </a:solidFill>
+                <a:latin typeface="Calibri" pitchFamily="34" charset="0"/>
+                <a:ea typeface="Calibri" pitchFamily="34" charset="-122"/>
+                <a:cs typeface="Calibri" pitchFamily="34" charset="-120"/>
+              </a:rPr>
+              <a:t>Google, Microsoft o GitHub</a:t>
+            </a:r>
+            <a:endParaRPr lang="en-US" sz="1600" dirty="0"/>
+          </a:p>
+          <a:p>
+            <a:pPr marL="342900" indent="-342900">
+              <a:spcAft>
+                <a:spcPts val="600"/>
+              </a:spcAft>
+              <a:buSzPct val="100000"/>
+              <a:buChar char="•"/>
+            </a:pPr>
+            <a:r>
+              <a:rPr lang="en-US" sz="1600" dirty="0">
+                <a:solidFill>
+                  <a:srgbClr val="22253A"/>
+                </a:solidFill>
+                <a:latin typeface="Calibri" pitchFamily="34" charset="0"/>
+                <a:ea typeface="Calibri" pitchFamily="34" charset="-122"/>
+                <a:cs typeface="Calibri" pitchFamily="34" charset="-120"/>
+              </a:rPr>
+              <a:t>Verifica in due passaggi OBBLIGATORIA</a:t>
+            </a:r>
+            <a:endParaRPr lang="en-US" sz="1600" dirty="0"/>
+          </a:p>
+          <a:p>
+            <a:pPr marL="342900" indent="-342900">
+              <a:spcAft>
+                <a:spcPts val="600"/>
+              </a:spcAft>
+              <a:buSzPct val="100000"/>
+              <a:buChar char="•"/>
+            </a:pPr>
+            <a:r>
+              <a:rPr lang="en-US" sz="1600" dirty="0">
+                <a:solidFill>
+                  <a:srgbClr val="22253A"/>
+                </a:solidFill>
+                <a:latin typeface="Calibri" pitchFamily="34" charset="0"/>
+                <a:ea typeface="Calibri" pitchFamily="34" charset="-122"/>
+                <a:cs typeface="Calibri" pitchFamily="34" charset="-120"/>
+              </a:rPr>
+              <a:t>Senza: la VPN avrebbe una password sola</a:t>
+            </a:r>
+            <a:endParaRPr lang="en-US" sz="1600" dirty="0"/>
+          </a:p>
+        </p:txBody>
+      </p:sp>
+      <p:sp>
+        <p:nvSpPr>
+          <p:cNvPr id="17" name="Shape 12"/>
+          <p:cNvSpPr/>
+          <p:nvPr/>
+        </p:nvSpPr>
+        <p:spPr>
+          <a:xfrm>
+            <a:off x="548640" y="4892040"/>
+            <a:ext cx="5440680" cy="1234440"/>
+          </a:xfrm>
+          <a:prstGeom prst="roundRect">
+            <a:avLst>
+              <a:gd name="adj" fmla="val 8889"/>
             </a:avLst>
           </a:prstGeom>
           <a:solidFill>
@@ -18741,13 +19141,13 @@
       </p:sp>
       <p:sp>
         <p:nvSpPr>
-          <p:cNvPr id="8" name="Shape 5"/>
+          <p:cNvPr id="18" name="Shape 13"/>
           <p:cNvSpPr/>
           <p:nvPr/>
         </p:nvSpPr>
         <p:spPr>
           <a:xfrm>
-            <a:off x="777240" y="2651760"/>
+            <a:off x="777240" y="5120640"/>
             <a:ext cx="548640" cy="548640"/>
           </a:xfrm>
           <a:prstGeom prst="ellipse">
@@ -18766,21 +19166,21 @@
       </p:sp>
       <p:pic>
         <p:nvPicPr>
-          <p:cNvPr id="9" name="Image 0" descr="preencoded.png">    </p:cNvPr>
+          <p:cNvPr id="19" name="Image 2" descr="preencoded.png">    </p:cNvPr>
           <p:cNvPicPr>
             <a:picLocks noChangeAspect="1"/>
           </p:cNvPicPr>
           <p:nvPr/>
         </p:nvPicPr>
         <p:blipFill>
-          <a:blip r:embed="rId1"/>
+          <a:blip r:embed="rId3"/>
           <a:stretch>
             <a:fillRect/>
           </a:stretch>
         </p:blipFill>
         <p:spPr>
           <a:xfrm>
-            <a:off x="914400" y="2788920"/>
+            <a:off x="914400" y="5257800"/>
             <a:ext cx="274320" cy="274320"/>
           </a:xfrm>
           <a:prstGeom prst="rect">
@@ -18790,13 +19190,13 @@
       </p:pic>
       <p:sp>
         <p:nvSpPr>
-          <p:cNvPr id="10" name="Text 6"/>
+          <p:cNvPr id="20" name="Text 14"/>
           <p:cNvSpPr txBox="1"/>
           <p:nvPr/>
         </p:nvSpPr>
         <p:spPr>
           <a:xfrm>
-            <a:off x="1508760" y="2651760"/>
+            <a:off x="1508760" y="5120640"/>
             <a:ext cx="4251960" cy="548640"/>
           </a:xfrm>
           <a:prstGeom prst="rect">
@@ -18821,7 +19221,7 @@
                 <a:ea typeface="Calibri" pitchFamily="34" charset="-122"/>
                 <a:cs typeface="Calibri" pitchFamily="34" charset="-120"/>
               </a:rPr>
-              <a:t>Login con un account esistente</a:t>
+              <a:t>Nei gruppi: il nome di login</a:t>
             </a:r>
             <a:endParaRPr lang="en-US" sz="1800" dirty="0"/>
           </a:p>
@@ -18829,14 +19229,14 @@
       </p:sp>
       <p:sp>
         <p:nvSpPr>
-          <p:cNvPr id="11" name="Text 7"/>
+          <p:cNvPr id="21" name="Text 15"/>
           <p:cNvSpPr txBox="1"/>
           <p:nvPr/>
         </p:nvSpPr>
         <p:spPr>
           <a:xfrm>
-            <a:off x="777240" y="3337560"/>
-            <a:ext cx="4983480" cy="548640"/>
+            <a:off x="777240" y="5806440"/>
+            <a:ext cx="4983480" cy="137160"/>
           </a:xfrm>
           <a:prstGeom prst="rect">
             <a:avLst/>
@@ -18855,7 +19255,7 @@
               <a:buNone/>
             </a:pPr>
             <a:r>
-              <a:rPr lang="en-US" sz="1600" dirty="0">
+              <a:rPr lang="en-US" sz="1500" dirty="0">
                 <a:solidFill>
                   <a:srgbClr val="22253A"/>
                 </a:solidFill>
@@ -18863,183 +19263,26 @@
                 <a:ea typeface="Calibri" pitchFamily="34" charset="-122"/>
                 <a:cs typeface="Calibri" pitchFamily="34" charset="-120"/>
               </a:rPr>
-              <a:t>Google, Microsoft, GitHub… Tailscale non ha password sue</a:t>
-            </a:r>
-            <a:endParaRPr lang="en-US" sz="1600" dirty="0"/>
-          </a:p>
-        </p:txBody>
-      </p:sp>
-      <p:sp>
-        <p:nvSpPr>
-          <p:cNvPr id="12" name="Shape 8"/>
+              <a:t>lo trovi nella console di Tailscale, alla voce Users</a:t>
+            </a:r>
+            <a:endParaRPr lang="en-US" sz="1500" dirty="0"/>
+          </a:p>
+        </p:txBody>
+      </p:sp>
+      <p:sp>
+        <p:nvSpPr>
+          <p:cNvPr id="22" name="Shape 16"/>
           <p:cNvSpPr/>
           <p:nvPr/>
         </p:nvSpPr>
         <p:spPr>
           <a:xfrm>
-            <a:off x="6172200" y="2423160"/>
-            <a:ext cx="5440680" cy="1645920"/>
+            <a:off x="6172200" y="4892040"/>
+            <a:ext cx="5468112" cy="1234440"/>
           </a:xfrm>
           <a:prstGeom prst="roundRect">
             <a:avLst>
-              <a:gd name="adj" fmla="val 6667"/>
-            </a:avLst>
-          </a:prstGeom>
-          <a:solidFill>
-            <a:srgbClr val="FDF0E3"/>
-          </a:solidFill>
-          <a:ln w="12700">
-            <a:solidFill>
-              <a:srgbClr val="FDF0E3"/>
-            </a:solidFill>
-            <a:prstDash val="solid"/>
-          </a:ln>
-        </p:spPr>
-      </p:sp>
-      <p:sp>
-        <p:nvSpPr>
-          <p:cNvPr id="13" name="Shape 9"/>
-          <p:cNvSpPr/>
-          <p:nvPr/>
-        </p:nvSpPr>
-        <p:spPr>
-          <a:xfrm>
-            <a:off x="6400800" y="2651760"/>
-            <a:ext cx="548640" cy="548640"/>
-          </a:xfrm>
-          <a:prstGeom prst="ellipse">
-            <a:avLst/>
-          </a:prstGeom>
-          <a:solidFill>
-            <a:srgbClr val="F28C28"/>
-          </a:solidFill>
-          <a:ln w="12700">
-            <a:solidFill>
-              <a:srgbClr val="F28C28"/>
-            </a:solidFill>
-            <a:prstDash val="solid"/>
-          </a:ln>
-        </p:spPr>
-      </p:sp>
-      <p:pic>
-        <p:nvPicPr>
-          <p:cNvPr id="14" name="Image 1" descr="preencoded.png">    </p:cNvPr>
-          <p:cNvPicPr>
-            <a:picLocks noChangeAspect="1"/>
-          </p:cNvPicPr>
-          <p:nvPr/>
-        </p:nvPicPr>
-        <p:blipFill>
-          <a:blip r:embed="rId2"/>
-          <a:stretch>
-            <a:fillRect/>
-          </a:stretch>
-        </p:blipFill>
-        <p:spPr>
-          <a:xfrm>
-            <a:off x="6537960" y="2788920"/>
-            <a:ext cx="274320" cy="274320"/>
-          </a:xfrm>
-          <a:prstGeom prst="rect">
-            <a:avLst/>
-          </a:prstGeom>
-        </p:spPr>
-      </p:pic>
-      <p:sp>
-        <p:nvSpPr>
-          <p:cNvPr id="15" name="Text 10"/>
-          <p:cNvSpPr txBox="1"/>
-          <p:nvPr/>
-        </p:nvSpPr>
-        <p:spPr>
-          <a:xfrm>
-            <a:off x="7132320" y="2651760"/>
-            <a:ext cx="4251960" cy="548640"/>
-          </a:xfrm>
-          <a:prstGeom prst="rect">
-            <a:avLst/>
-          </a:prstGeom>
-          <a:noFill/>
-          <a:ln/>
-        </p:spPr>
-        <p:txBody>
-          <a:bodyPr wrap="square" lIns="0" tIns="0" rIns="0" bIns="0" rtlCol="0" anchor="ctr"/>
-          <a:lstStyle/>
-          <a:p>
-            <a:pPr indent="0" marL="0">
-              <a:buNone/>
-            </a:pPr>
-            <a:r>
-              <a:rPr lang="en-US" sz="1800" b="1" dirty="0">
-                <a:solidFill>
-                  <a:srgbClr val="22253A"/>
-                </a:solidFill>
-                <a:latin typeface="Calibri" pitchFamily="34" charset="0"/>
-                <a:ea typeface="Calibri" pitchFamily="34" charset="-122"/>
-                <a:cs typeface="Calibri" pitchFamily="34" charset="-120"/>
-              </a:rPr>
-              <a:t>MFA del servizio di login</a:t>
-            </a:r>
-            <a:endParaRPr lang="en-US" sz="1800" dirty="0"/>
-          </a:p>
-        </p:txBody>
-      </p:sp>
-      <p:sp>
-        <p:nvSpPr>
-          <p:cNvPr id="16" name="Text 11"/>
-          <p:cNvSpPr txBox="1"/>
-          <p:nvPr/>
-        </p:nvSpPr>
-        <p:spPr>
-          <a:xfrm>
-            <a:off x="6400800" y="3337560"/>
-            <a:ext cx="4983480" cy="548640"/>
-          </a:xfrm>
-          <a:prstGeom prst="rect">
-            <a:avLst/>
-          </a:prstGeom>
-          <a:noFill/>
-          <a:ln/>
-        </p:spPr>
-        <p:txBody>
-          <a:bodyPr wrap="square" lIns="0" tIns="0" rIns="0" bIns="0" rtlCol="0" anchor="t"/>
-          <a:lstStyle/>
-          <a:p>
-            <a:pPr indent="0" marL="0">
-              <a:spcAft>
-                <a:spcPts val="600"/>
-              </a:spcAft>
-              <a:buNone/>
-            </a:pPr>
-            <a:r>
-              <a:rPr lang="en-US" sz="1600" dirty="0">
-                <a:solidFill>
-                  <a:srgbClr val="22253A"/>
-                </a:solidFill>
-                <a:latin typeface="Calibri" pitchFamily="34" charset="0"/>
-                <a:ea typeface="Calibri" pitchFamily="34" charset="-122"/>
-                <a:cs typeface="Calibri" pitchFamily="34" charset="-120"/>
-              </a:rPr>
-              <a:t>password + codice dal telefono, se l'account ce l'ha attiva</a:t>
-            </a:r>
-            <a:endParaRPr lang="en-US" sz="1600" dirty="0"/>
-          </a:p>
-        </p:txBody>
-      </p:sp>
-      <p:sp>
-        <p:nvSpPr>
-          <p:cNvPr id="17" name="Shape 12"/>
-          <p:cNvSpPr/>
-          <p:nvPr/>
-        </p:nvSpPr>
-        <p:spPr>
-          <a:xfrm>
-            <a:off x="548640" y="4251960"/>
-            <a:ext cx="5440680" cy="1645920"/>
-          </a:xfrm>
-          <a:prstGeom prst="roundRect">
-            <a:avLst>
-              <a:gd name="adj" fmla="val 6667"/>
+              <a:gd name="adj" fmla="val 8889"/>
             </a:avLst>
           </a:prstGeom>
           <a:solidFill>
@@ -19055,13 +19298,13 @@
       </p:sp>
       <p:sp>
         <p:nvSpPr>
-          <p:cNvPr id="18" name="Shape 13"/>
+          <p:cNvPr id="23" name="Shape 17"/>
           <p:cNvSpPr/>
           <p:nvPr/>
         </p:nvSpPr>
         <p:spPr>
           <a:xfrm>
-            <a:off x="777240" y="4480560"/>
+            <a:off x="6400800" y="5120640"/>
             <a:ext cx="548640" cy="548640"/>
           </a:xfrm>
           <a:prstGeom prst="ellipse">
@@ -19080,163 +19323,6 @@
       </p:sp>
       <p:pic>
         <p:nvPicPr>
-          <p:cNvPr id="19" name="Image 2" descr="preencoded.png">    </p:cNvPr>
-          <p:cNvPicPr>
-            <a:picLocks noChangeAspect="1"/>
-          </p:cNvPicPr>
-          <p:nvPr/>
-        </p:nvPicPr>
-        <p:blipFill>
-          <a:blip r:embed="rId3"/>
-          <a:stretch>
-            <a:fillRect/>
-          </a:stretch>
-        </p:blipFill>
-        <p:spPr>
-          <a:xfrm>
-            <a:off x="914400" y="4617720"/>
-            <a:ext cx="274320" cy="274320"/>
-          </a:xfrm>
-          <a:prstGeom prst="rect">
-            <a:avLst/>
-          </a:prstGeom>
-        </p:spPr>
-      </p:pic>
-      <p:sp>
-        <p:nvSpPr>
-          <p:cNvPr id="20" name="Text 14"/>
-          <p:cNvSpPr txBox="1"/>
-          <p:nvPr/>
-        </p:nvSpPr>
-        <p:spPr>
-          <a:xfrm>
-            <a:off x="1508760" y="4480560"/>
-            <a:ext cx="4251960" cy="548640"/>
-          </a:xfrm>
-          <a:prstGeom prst="rect">
-            <a:avLst/>
-          </a:prstGeom>
-          <a:noFill/>
-          <a:ln/>
-        </p:spPr>
-        <p:txBody>
-          <a:bodyPr wrap="square" lIns="0" tIns="0" rIns="0" bIns="0" rtlCol="0" anchor="ctr"/>
-          <a:lstStyle/>
-          <a:p>
-            <a:pPr indent="0" marL="0">
-              <a:buNone/>
-            </a:pPr>
-            <a:r>
-              <a:rPr lang="en-US" sz="1800" b="1" dirty="0">
-                <a:solidFill>
-                  <a:srgbClr val="22253A"/>
-                </a:solidFill>
-                <a:latin typeface="Calibri" pitchFamily="34" charset="0"/>
-                <a:ea typeface="Calibri" pitchFamily="34" charset="-122"/>
-                <a:cs typeface="Calibri" pitchFamily="34" charset="-120"/>
-              </a:rPr>
-              <a:t>Scadenza e approvazione</a:t>
-            </a:r>
-            <a:endParaRPr lang="en-US" sz="1800" dirty="0"/>
-          </a:p>
-        </p:txBody>
-      </p:sp>
-      <p:sp>
-        <p:nvSpPr>
-          <p:cNvPr id="21" name="Text 15"/>
-          <p:cNvSpPr txBox="1"/>
-          <p:nvPr/>
-        </p:nvSpPr>
-        <p:spPr>
-          <a:xfrm>
-            <a:off x="777240" y="5166360"/>
-            <a:ext cx="4983480" cy="548640"/>
-          </a:xfrm>
-          <a:prstGeom prst="rect">
-            <a:avLst/>
-          </a:prstGeom>
-          <a:noFill/>
-          <a:ln/>
-        </p:spPr>
-        <p:txBody>
-          <a:bodyPr wrap="square" lIns="0" tIns="0" rIns="0" bIns="0" rtlCol="0" anchor="t"/>
-          <a:lstStyle/>
-          <a:p>
-            <a:pPr indent="0" marL="0">
-              <a:spcAft>
-                <a:spcPts val="600"/>
-              </a:spcAft>
-              <a:buNone/>
-            </a:pPr>
-            <a:r>
-              <a:rPr lang="en-US" sz="1600" dirty="0">
-                <a:solidFill>
-                  <a:srgbClr val="22253A"/>
-                </a:solidFill>
-                <a:latin typeface="Calibri" pitchFamily="34" charset="0"/>
-                <a:ea typeface="Calibri" pitchFamily="34" charset="-122"/>
-                <a:cs typeface="Calibri" pitchFamily="34" charset="-120"/>
-              </a:rPr>
-              <a:t>il login dei dispositivi scade; i nuovi si possono far approvare</a:t>
-            </a:r>
-            <a:endParaRPr lang="en-US" sz="1600" dirty="0"/>
-          </a:p>
-        </p:txBody>
-      </p:sp>
-      <p:sp>
-        <p:nvSpPr>
-          <p:cNvPr id="22" name="Shape 16"/>
-          <p:cNvSpPr/>
-          <p:nvPr/>
-        </p:nvSpPr>
-        <p:spPr>
-          <a:xfrm>
-            <a:off x="6172200" y="4251960"/>
-            <a:ext cx="5440680" cy="1645920"/>
-          </a:xfrm>
-          <a:prstGeom prst="roundRect">
-            <a:avLst>
-              <a:gd name="adj" fmla="val 6667"/>
-            </a:avLst>
-          </a:prstGeom>
-          <a:solidFill>
-            <a:srgbClr val="EEEAFB"/>
-          </a:solidFill>
-          <a:ln w="12700">
-            <a:solidFill>
-              <a:srgbClr val="EEEAFB"/>
-            </a:solidFill>
-            <a:prstDash val="solid"/>
-          </a:ln>
-        </p:spPr>
-      </p:sp>
-      <p:sp>
-        <p:nvSpPr>
-          <p:cNvPr id="23" name="Shape 17"/>
-          <p:cNvSpPr/>
-          <p:nvPr/>
-        </p:nvSpPr>
-        <p:spPr>
-          <a:xfrm>
-            <a:off x="6400800" y="4480560"/>
-            <a:ext cx="548640" cy="548640"/>
-          </a:xfrm>
-          <a:prstGeom prst="ellipse">
-            <a:avLst/>
-          </a:prstGeom>
-          <a:solidFill>
-            <a:srgbClr val="5B3FD0"/>
-          </a:solidFill>
-          <a:ln w="12700">
-            <a:solidFill>
-              <a:srgbClr val="5B3FD0"/>
-            </a:solidFill>
-            <a:prstDash val="solid"/>
-          </a:ln>
-        </p:spPr>
-      </p:sp>
-      <p:pic>
-        <p:nvPicPr>
           <p:cNvPr id="24" name="Image 3" descr="preencoded.png">    </p:cNvPr>
           <p:cNvPicPr>
             <a:picLocks noChangeAspect="1"/>
@@ -19251,7 +19337,7 @@
         </p:blipFill>
         <p:spPr>
           <a:xfrm>
-            <a:off x="6537960" y="4617720"/>
+            <a:off x="6537960" y="5257800"/>
             <a:ext cx="274320" cy="274320"/>
           </a:xfrm>
           <a:prstGeom prst="rect">
@@ -19267,8 +19353,8 @@
         </p:nvSpPr>
         <p:spPr>
           <a:xfrm>
-            <a:off x="7132320" y="4480560"/>
-            <a:ext cx="4251960" cy="548640"/>
+            <a:off x="7132320" y="5120640"/>
+            <a:ext cx="4279392" cy="548640"/>
           </a:xfrm>
           <a:prstGeom prst="rect">
             <a:avLst/>
@@ -19292,7 +19378,7 @@
                 <a:ea typeface="Calibri" pitchFamily="34" charset="-122"/>
                 <a:cs typeface="Calibri" pitchFamily="34" charset="-120"/>
               </a:rPr>
-              <a:t>Chi lascia l'azienda</a:t>
+              <a:t>Chi lascia il gruppo</a:t>
             </a:r>
             <a:endParaRPr lang="en-US" sz="1800" dirty="0"/>
           </a:p>
@@ -19306,8 +19392,8 @@
         </p:nvSpPr>
         <p:spPr>
           <a:xfrm>
-            <a:off x="6400800" y="5166360"/>
-            <a:ext cx="4983480" cy="548640"/>
+            <a:off x="6400800" y="5806440"/>
+            <a:ext cx="5010912" cy="137160"/>
           </a:xfrm>
           <a:prstGeom prst="rect">
             <a:avLst/>
@@ -19326,7 +19412,7 @@
               <a:buNone/>
             </a:pPr>
             <a:r>
-              <a:rPr lang="en-US" sz="1600" dirty="0">
+              <a:rPr lang="en-US" sz="1500" dirty="0">
                 <a:solidFill>
                   <a:srgbClr val="22253A"/>
                 </a:solidFill>
@@ -19334,9 +19420,9 @@
                 <a:ea typeface="Calibri" pitchFamily="34" charset="-122"/>
                 <a:cs typeface="Calibri" pitchFamily="34" charset="-120"/>
               </a:rPr>
-              <a:t>si disattiva il suo account: perde subito l'accesso</a:t>
-            </a:r>
-            <a:endParaRPr lang="en-US" sz="1600" dirty="0"/>
+              <a:t>si rimuove da Tailscale (Users): perde subito l'accesso</a:t>
+            </a:r>
+            <a:endParaRPr lang="en-US" sz="1500" dirty="0"/>
           </a:p>
         </p:txBody>
       </p:sp>
@@ -19885,7 +19971,7 @@
                           <a:ea typeface="Calibri" pitchFamily="34" charset="-122"/>
                           <a:cs typeface="Calibri" pitchFamily="34" charset="-120"/>
                         </a:rPr>
-                        <a:t>group:admin e group:dev, con le email</a:t>
+                        <a:t>group:admin e group:dev, con i nomi di login</a:t>
                       </a:r>
                       <a:endParaRPr lang="en-US" sz="1600" dirty="0">
                         <a:latin typeface="Calibri" charset="0"/>

</xml_diff>

<commit_message>
Lezione 8: deploy end-to-end (dispensa e slide); router Tailscale con role proprio; nota sulla chiave del router
</commit_message>
<xml_diff>
--- a/slide/slide-5-tailscale.pptx
+++ b/slide/slide-5-tailscale.pptx
@@ -699,7 +699,7 @@
           <a:p>
             <a:r>
               <a:rPr lang="en-US" dirty="0"/>
-              <a:t>Il router è un server EC2 come quello della lezione 4, con poche differenze: il tipo più piccolo, t4g.nano; il Security Group vpn invece di app; uno user_data che installa Tailscale invece dell'applicazione; niente in ingresso. Per entrarci per manutenzione, SSM, come per il server, usando lo stesso instance profile. Due cose nuove. L'inoltro dei pacchetti: un server Linux normalmente scarta i pacchetti che non sono per lui; un router deve inoltrarli, e si attiva con l'impostazione ip_forward. E la chiave d'ingresso, che vediamo tra poco.</a:t>
+              <a:t>Il router è un server EC2 come quello della lezione 4, con poche differenze: il tipo più piccolo, t4g.nano; il Security Group vpn invece di app; uno user_data che installa Tailscale invece dell'applicazione; niente in ingresso. Per entrarci per manutenzione, SSM, come per il server, ma con un role tutto suo che ha solo i permessi di SSM: il role del server dell'applicazione, nelle prossime lezioni, riceverà altri permessi che al router non servono. Due cose nuove. L'inoltro dei pacchetti: un server Linux normalmente scarta i pacchetti che non sono per lui; un router deve inoltrarli, e si attiva con l'impostazione ip_forward. E la chiave d'ingresso, che vediamo tra poco.</a:t>
             </a:r>
             <a:endParaRPr lang="en-US" dirty="0"/>
           </a:p>
@@ -1227,7 +1227,7 @@
           <a:p>
             <a:r>
               <a:rPr lang="en-US" dirty="0"/>
-              <a:t>Il router è lo schema della lezione 4: AMI dal parametro, t4g.nano, subnet privata, Security Group vpn, lo stesso instance profile perché gli serve solo SSM. Lo script fa tre cose: attiva l'inoltro dei pacchetti e lo rende permanente; installa Tailscale con lo script ufficiale; lancia tailscale up, che entra nel tailnet con la chiave, si dà un nome e un'etichetta, e annuncia le subnet. join unisce la lista delle subnet in un testo separato da virgole.</a:t>
+              <a:t>Il router è lo schema della lezione 4: AMI dal parametro, t4g.nano, subnet privata, Security Group vpn, un instance profile suo, router, con un role che ha solo la policy di SSM: ogni server ha il suo role, con i permessi che servono a lui. Lo script fa tre cose: attiva l'inoltro dei pacchetti e lo rende permanente; installa Tailscale con lo script ufficiale; lancia tailscale up, che entra nel tailnet con la chiave, si dà un nome e un'etichetta, e annuncia le subnet. join unisce la lista delle subnet in un testo separato da virgole.</a:t>
             </a:r>
             <a:endParaRPr lang="en-US" dirty="0"/>
           </a:p>
@@ -5239,7 +5239,7 @@
                           <a:ea typeface="Calibri" pitchFamily="34" charset="-122"/>
                           <a:cs typeface="Calibri" pitchFamily="34" charset="-120"/>
                         </a:rPr>
-                        <a:t>SSM (stesso instance profile)</a:t>
+                        <a:t>SSM (role suo, solo SSM)</a:t>
                       </a:r>
                       <a:endParaRPr lang="en-US" sz="1600" dirty="0">
                         <a:latin typeface="Calibri" charset="0"/>
@@ -10246,7 +10246,7 @@
                 <a:ea typeface="Courier New" pitchFamily="34" charset="-122"/>
                 <a:cs typeface="Courier New" pitchFamily="34" charset="-120"/>
               </a:rPr>
-              <a:t>  iam_instance_profile   = aws_iam_instance_profile.app.name   </a:t>
+              <a:t>  iam_instance_profile   = aws_iam_instance_profile.router.name   </a:t>
             </a:r>
             <a:pPr indent="0" marL="0">
               <a:buNone/>
@@ -10260,7 +10260,7 @@
                 <a:ea typeface="Courier New" pitchFamily="34" charset="-122"/>
                 <a:cs typeface="Courier New" pitchFamily="34" charset="-120"/>
               </a:rPr>
-              <a:t># solo SSM</a:t>
+              <a:t># role suo: solo SSM</a:t>
             </a:r>
             <a:endParaRPr lang="en-US" sz="1400" dirty="0"/>
           </a:p>

</xml_diff>